<commit_message>
feat: enhance reporting framework modules
</commit_message>
<xml_diff>
--- a/Test Client-report.pptx
+++ b/Test Client-report.pptx
@@ -110,6 +110,305 @@
     </a:lvl9pPr>
   </p:defaultTextStyle>
 </p:presentation>
+</file>
+
+<file path=ppt/charts/chart1.xml><?xml version="1.0" encoding="utf-8"?>
+<c:chartSpace xmlns:c="http://schemas.openxmlformats.org/drawingml/2006/chart" xmlns:a="http://schemas.openxmlformats.org/drawingml/2006/main" xmlns:r="http://schemas.openxmlformats.org/officeDocument/2006/relationships">
+  <c:date1904 val="0"/>
+  <c:roundedCorners val="1"/>
+  <c:chart>
+    <c:autoTitleDeleted val="1"/>
+    <c:plotArea>
+      <c:layout/>
+      <c:barChart>
+        <c:barDir val="col"/>
+        <c:grouping val="clustered"/>
+        <c:varyColors val="0"/>
+        <c:ser>
+          <c:idx val="0"/>
+          <c:order val="0"/>
+          <c:tx>
+            <c:strRef>
+              <c:f>Sheet1!$B$1</c:f>
+              <c:strCache>
+                <c:ptCount val="1"/>
+                <c:pt idx="0">
+                  <c:v>Location</c:v>
+                </c:pt>
+              </c:strCache>
+            </c:strRef>
+          </c:tx>
+          <c:spPr>
+            <a:solidFill>
+              <a:srgbClr val="C0504D"/>
+            </a:solidFill>
+            <a:effectLst/>
+          </c:spPr>
+          <c:invertIfNegative val="0"/>
+          <c:dLbls>
+            <c:numFmt formatCode="#,##0" sourceLinked="0"/>
+            <c:txPr>
+              <a:bodyPr/>
+              <a:lstStyle/>
+              <a:p>
+                <a:pPr>
+                  <a:defRPr b="0" i="0" strike="noStrike" sz="1200" u="none">
+                    <a:solidFill>
+                      <a:srgbClr val="000000"/>
+                    </a:solidFill>
+                    <a:latin typeface="Arial"/>
+                  </a:defRPr>
+                </a:pPr>
+              </a:p>
+            </c:txPr>
+            <c:showLegendKey val="0"/>
+            <c:showVal val="0"/>
+            <c:showCatName val="0"/>
+            <c:showSerName val="0"/>
+            <c:showPercent val="0"/>
+            <c:showBubbleSize val="0"/>
+            <c:showLeaderLines val="0"/>
+          </c:dLbls>
+          <c:cat>
+            <c:multiLvlStrRef>
+              <c:f>Sheet1!$A$2:$A$2</c:f>
+              <c:multiLvlStrCache>
+                <c:ptCount val="1"/>
+                <c:lvl>
+                  <c:pt idx="0">
+                    <c:v>Global</c:v>
+                  </c:pt>
+                </c:lvl>
+              </c:multiLvlStrCache>
+            </c:multiLvlStrRef>
+          </c:cat>
+          <c:val>
+            <c:numRef>
+              <c:f>Sheet1!$B$2:$B$2</c:f>
+              <c:numCache>
+                <c:formatCode>General</c:formatCode>
+                <c:ptCount val="1"/>
+                <c:pt idx="0">
+                  <c:v>1</c:v>
+                </c:pt>
+              </c:numCache>
+            </c:numRef>
+          </c:val>
+        </c:ser>
+        <c:ser>
+          <c:idx val="1"/>
+          <c:order val="1"/>
+          <c:tx>
+            <c:strRef>
+              <c:f>Sheet1!$C$1</c:f>
+              <c:strCache>
+                <c:ptCount val="1"/>
+                <c:pt idx="0">
+                  <c:v>Gender</c:v>
+                </c:pt>
+              </c:strCache>
+            </c:strRef>
+          </c:tx>
+          <c:spPr>
+            <a:solidFill>
+              <a:srgbClr val="4F81BD"/>
+            </a:solidFill>
+            <a:effectLst/>
+          </c:spPr>
+          <c:invertIfNegative val="0"/>
+          <c:dLbls>
+            <c:numFmt formatCode="#,##0" sourceLinked="0"/>
+            <c:txPr>
+              <a:bodyPr/>
+              <a:lstStyle/>
+              <a:p>
+                <a:pPr>
+                  <a:defRPr b="0" i="0" strike="noStrike" sz="1200" u="none">
+                    <a:solidFill>
+                      <a:srgbClr val="000000"/>
+                    </a:solidFill>
+                    <a:latin typeface="Arial"/>
+                  </a:defRPr>
+                </a:pPr>
+              </a:p>
+            </c:txPr>
+            <c:showLegendKey val="0"/>
+            <c:showVal val="0"/>
+            <c:showCatName val="0"/>
+            <c:showSerName val="0"/>
+            <c:showPercent val="0"/>
+            <c:showBubbleSize val="0"/>
+            <c:showLeaderLines val="0"/>
+          </c:dLbls>
+          <c:cat>
+            <c:multiLvlStrRef>
+              <c:f>Sheet1!$A$2:$A$2</c:f>
+              <c:multiLvlStrCache>
+                <c:ptCount val="1"/>
+                <c:lvl>
+                  <c:pt idx="0">
+                    <c:v>Mixed</c:v>
+                  </c:pt>
+                </c:lvl>
+              </c:multiLvlStrCache>
+            </c:multiLvlStrRef>
+          </c:cat>
+          <c:val>
+            <c:numRef>
+              <c:f>Sheet1!$C$2:$C$2</c:f>
+              <c:numCache>
+                <c:formatCode>General</c:formatCode>
+                <c:ptCount val="1"/>
+                <c:pt idx="0">
+                  <c:v>1</c:v>
+                </c:pt>
+              </c:numCache>
+            </c:numRef>
+          </c:val>
+        </c:ser>
+        <c:dLbls>
+          <c:numFmt formatCode="#,##0" sourceLinked="0"/>
+          <c:txPr>
+            <a:bodyPr/>
+            <a:lstStyle/>
+            <a:p>
+              <a:pPr>
+                <a:defRPr b="0" i="0" strike="noStrike" sz="1200" u="none">
+                  <a:solidFill>
+                    <a:srgbClr val="000000"/>
+                  </a:solidFill>
+                  <a:latin typeface="Arial"/>
+                </a:defRPr>
+              </a:pPr>
+            </a:p>
+          </c:txPr>
+          <c:showLegendKey val="0"/>
+          <c:showVal val="0"/>
+          <c:showCatName val="0"/>
+          <c:showSerName val="0"/>
+          <c:showPercent val="0"/>
+          <c:showBubbleSize val="0"/>
+          <c:showLeaderLines val="0"/>
+        </c:dLbls>
+        <c:gapWidth val="150"/>
+        <c:overlap val="0"/>
+        <c:axId val="2094734554"/>
+        <c:axId val="2094734552"/>
+        <c:axId val="2094734556"/>
+      </c:barChart>
+      <c:catAx>
+        <c:axId val="2094734554"/>
+        <c:scaling>
+          <c:orientation val="minMax"/>
+        </c:scaling>
+        <c:delete val="0"/>
+        <c:axPos val="b"/>
+        <c:numFmt formatCode="General" sourceLinked="1"/>
+        <c:majorTickMark val="out"/>
+        <c:minorTickMark val="none"/>
+        <c:tickLblPos val="low"/>
+        <c:spPr>
+          <a:ln w="12700" cap="flat">
+            <a:solidFill>
+              <a:srgbClr val="888888"/>
+            </a:solidFill>
+            <a:prstDash val="solid"/>
+            <a:round/>
+          </a:ln>
+        </c:spPr>
+        <c:txPr>
+          <a:bodyPr/>
+          <a:lstStyle/>
+          <a:p>
+            <a:pPr>
+              <a:defRPr sz="1200" b="0" i="0" u="none" strike="noStrike">
+                <a:solidFill>
+                  <a:srgbClr val="000000"/>
+                </a:solidFill>
+                <a:latin typeface="Arial"/>
+              </a:defRPr>
+            </a:pPr>
+            <a:endParaRPr lang="en-US"/>
+          </a:p>
+        </c:txPr>
+        <c:crossAx val="2094734552"/>
+        <c:crosses val="autoZero"/>
+        <c:auto val="1"/>
+        <c:lblAlgn val="ctr"/>
+        <c:noMultiLvlLbl val="1"/>
+      </c:catAx>
+      <c:valAx>
+        <c:axId val="2094734552"/>
+        <c:scaling>
+          <c:orientation val="minMax"/>
+        </c:scaling>
+        <c:delete val="0"/>
+        <c:axPos val="l"/>
+        <c:majorGridlines>
+          <c:spPr>
+            <a:ln w="12700" cap="flat">
+              <a:solidFill>
+                <a:srgbClr val="888888"/>
+              </a:solidFill>
+              <a:prstDash val="solid"/>
+              <a:round/>
+            </a:ln>
+          </c:spPr>
+        </c:majorGridlines>
+        <c:numFmt formatCode="General" sourceLinked="0"/>
+        <c:majorTickMark val="out"/>
+        <c:minorTickMark val="none"/>
+        <c:tickLblPos val="nextTo"/>
+        <c:spPr>
+          <a:ln w="12700" cap="flat">
+            <a:solidFill>
+              <a:srgbClr val="888888"/>
+            </a:solidFill>
+            <a:prstDash val="solid"/>
+            <a:round/>
+          </a:ln>
+        </c:spPr>
+        <c:txPr>
+          <a:bodyPr/>
+          <a:lstStyle/>
+          <a:p>
+            <a:pPr>
+              <a:defRPr sz="1200" b="0" i="0" u="none" strike="noStrike">
+                <a:solidFill>
+                  <a:srgbClr val="000000"/>
+                </a:solidFill>
+                <a:latin typeface="Arial"/>
+              </a:defRPr>
+            </a:pPr>
+            <a:endParaRPr lang="en-US"/>
+          </a:p>
+        </c:txPr>
+        <c:crossAx val="2094734554"/>
+        <c:crosses val="autoZero"/>
+        <c:crossBetween val="between"/>
+      </c:valAx>
+      <c:spPr>
+        <a:noFill/>
+        <a:ln>
+          <a:noFill/>
+        </a:ln>
+        <a:effectLst/>
+      </c:spPr>
+    </c:plotArea>
+    <c:plotVisOnly val="1"/>
+    <c:dispBlanksAs val="span"/>
+  </c:chart>
+  <c:spPr>
+    <a:noFill/>
+    <a:ln>
+      <a:noFill/>
+    </a:ln>
+    <a:effectLst/>
+  </c:spPr>
+  <c:externalData r:id="rId1">
+    <c:autoUpdate val="0"/>
+  </c:externalData>
+</c:chartSpace>
 </file>
 
 <file path=ppt/notesMasters/notesMaster1.xml><?xml version="1.0" encoding="utf-8"?>
@@ -1334,7 +1633,43 @@
           <a:bodyPr wrap="square" rtlCol="0" anchor="ctr"/>
           <a:lstStyle/>
           <a:p>
-            <a:pPr indent="0" marL="0">
+            <a:pPr algn="ctr" indent="0" marL="0">
+              <a:buNone/>
+            </a:pPr>
+            <a:r>
+              <a:rPr lang="en-US" sz="3600" b="1" dirty="0">
+                <a:solidFill>
+                  <a:srgbClr val="000000"/>
+                </a:solidFill>
+              </a:rPr>
+              <a:t>Test Project</a:t>
+            </a:r>
+            <a:endParaRPr lang="en-US" sz="3600" dirty="0"/>
+          </a:p>
+        </p:txBody>
+      </p:sp>
+      <p:sp>
+        <p:nvSpPr>
+          <p:cNvPr id="3" name="Text 1"/>
+          <p:cNvSpPr/>
+          <p:nvPr/>
+        </p:nvSpPr>
+        <p:spPr>
+          <a:xfrm>
+            <a:off x="914400" y="1828800"/>
+            <a:ext cx="7315200" cy="914400"/>
+          </a:xfrm>
+          <a:prstGeom prst="rect">
+            <a:avLst/>
+          </a:prstGeom>
+          <a:noFill/>
+          <a:ln/>
+        </p:spPr>
+        <p:txBody>
+          <a:bodyPr wrap="square" rtlCol="0" anchor="ctr"/>
+          <a:lstStyle/>
+          <a:p>
+            <a:pPr algn="ctr" indent="0" marL="0">
               <a:buNone/>
             </a:pPr>
             <a:r>
@@ -1351,14 +1686,14 @@
       </p:sp>
       <p:sp>
         <p:nvSpPr>
-          <p:cNvPr id="3" name="Text 1"/>
+          <p:cNvPr id="4" name="Text 2"/>
           <p:cNvSpPr/>
           <p:nvPr/>
         </p:nvSpPr>
         <p:spPr>
           <a:xfrm>
-            <a:off x="914400" y="1828800"/>
-            <a:ext cx="7315200" cy="457200"/>
+            <a:off x="914400" y="3200400"/>
+            <a:ext cx="7315200" cy="914400"/>
           </a:xfrm>
           <a:prstGeom prst="rect">
             <a:avLst/>
@@ -1374,27 +1709,27 @@
               <a:buNone/>
             </a:pPr>
             <a:r>
-              <a:rPr lang="en-US" dirty="0">
+              <a:rPr lang="en-US" sz="1800" dirty="0">
                 <a:solidFill>
                   <a:srgbClr val="000000"/>
                 </a:solidFill>
               </a:rPr>
-              <a:t>Project Name: Test Project</a:t>
+              <a:t>Background: This is a test project.</a:t>
             </a:r>
-            <a:endParaRPr lang="en-US" dirty="0"/>
-          </a:p>
-        </p:txBody>
-      </p:sp>
-      <p:sp>
-        <p:nvSpPr>
-          <p:cNvPr id="4" name="Text 2"/>
+            <a:endParaRPr lang="en-US" sz="1800" dirty="0"/>
+          </a:p>
+        </p:txBody>
+      </p:sp>
+      <p:sp>
+        <p:nvSpPr>
+          <p:cNvPr id="5" name="Text 3"/>
           <p:cNvSpPr/>
           <p:nvPr/>
         </p:nvSpPr>
         <p:spPr>
           <a:xfrm>
-            <a:off x="914400" y="2286000"/>
-            <a:ext cx="7315200" cy="457200"/>
+            <a:off x="914400" y="4114800"/>
+            <a:ext cx="7315200" cy="914400"/>
           </a:xfrm>
           <a:prstGeom prst="rect">
             <a:avLst/>
@@ -1410,27 +1745,27 @@
               <a:buNone/>
             </a:pPr>
             <a:r>
-              <a:rPr lang="en-US" dirty="0">
+              <a:rPr lang="en-US" sz="1800" dirty="0">
                 <a:solidFill>
                   <a:srgbClr val="000000"/>
                 </a:solidFill>
               </a:rPr>
-              <a:t>Background: This is a test project.</a:t>
+              <a:t>Objectives: To test the reporting framework.</a:t>
             </a:r>
-            <a:endParaRPr lang="en-US" dirty="0"/>
-          </a:p>
-        </p:txBody>
-      </p:sp>
-      <p:sp>
-        <p:nvSpPr>
-          <p:cNvPr id="5" name="Text 3"/>
+            <a:endParaRPr lang="en-US" sz="1800" dirty="0"/>
+          </a:p>
+        </p:txBody>
+      </p:sp>
+      <p:sp>
+        <p:nvSpPr>
+          <p:cNvPr id="6" name="Text 4"/>
           <p:cNvSpPr/>
           <p:nvPr/>
         </p:nvSpPr>
         <p:spPr>
           <a:xfrm>
-            <a:off x="914400" y="2743200"/>
-            <a:ext cx="7315200" cy="457200"/>
+            <a:off x="914400" y="5029200"/>
+            <a:ext cx="7315200" cy="914400"/>
           </a:xfrm>
           <a:prstGeom prst="rect">
             <a:avLst/>
@@ -1446,50 +1781,14 @@
               <a:buNone/>
             </a:pPr>
             <a:r>
-              <a:rPr lang="en-US" dirty="0">
-                <a:solidFill>
-                  <a:srgbClr val="000000"/>
-                </a:solidFill>
-              </a:rPr>
-              <a:t>Objectives: To test the reporting framework.</a:t>
-            </a:r>
-            <a:endParaRPr lang="en-US" dirty="0"/>
-          </a:p>
-        </p:txBody>
-      </p:sp>
-      <p:sp>
-        <p:nvSpPr>
-          <p:cNvPr id="6" name="Text 4"/>
-          <p:cNvSpPr/>
-          <p:nvPr/>
-        </p:nvSpPr>
-        <p:spPr>
-          <a:xfrm>
-            <a:off x="914400" y="3200400"/>
-            <a:ext cx="7315200" cy="457200"/>
-          </a:xfrm>
-          <a:prstGeom prst="rect">
-            <a:avLst/>
-          </a:prstGeom>
-          <a:noFill/>
-          <a:ln/>
-        </p:spPr>
-        <p:txBody>
-          <a:bodyPr wrap="square" rtlCol="0" anchor="ctr"/>
-          <a:lstStyle/>
-          <a:p>
-            <a:pPr indent="0" marL="0">
-              <a:buNone/>
-            </a:pPr>
-            <a:r>
-              <a:rPr lang="en-US" dirty="0">
+              <a:rPr lang="en-US" sz="1800" dirty="0">
                 <a:solidFill>
                   <a:srgbClr val="000000"/>
                 </a:solidFill>
               </a:rPr>
               <a:t>Methodology: Agile development and testing.</a:t>
             </a:r>
-            <a:endParaRPr lang="en-US" dirty="0"/>
+            <a:endParaRPr lang="en-US" sz="1800" dirty="0"/>
           </a:p>
         </p:txBody>
       </p:sp>
@@ -1539,93 +1838,37 @@
           <a:bodyPr wrap="square" rtlCol="0" anchor="ctr"/>
           <a:lstStyle/>
           <a:p>
-            <a:pPr indent="0" marL="0">
+            <a:pPr algn="ctr" indent="0" marL="0">
               <a:buNone/>
             </a:pPr>
             <a:r>
-              <a:rPr lang="en-US" sz="2400" dirty="0">
+              <a:rPr lang="en-US" sz="3600" b="1" dirty="0">
                 <a:solidFill>
                   <a:srgbClr val="000000"/>
                 </a:solidFill>
               </a:rPr>
               <a:t>Respondent Profile</a:t>
             </a:r>
-            <a:endParaRPr lang="en-US" sz="2400" dirty="0"/>
-          </a:p>
-        </p:txBody>
-      </p:sp>
-      <p:sp>
-        <p:nvSpPr>
-          <p:cNvPr id="3" name="Text 1"/>
-          <p:cNvSpPr/>
+            <a:endParaRPr lang="en-US" sz="3600" dirty="0"/>
+          </a:p>
+        </p:txBody>
+      </p:sp>
+      <p:graphicFrame>
+        <p:nvGraphicFramePr>
+          <p:cNvPr id="3" name="Chart 0" descr=""/>
+          <p:cNvGraphicFramePr/>
           <p:nvPr/>
-        </p:nvSpPr>
-        <p:spPr>
-          <a:xfrm>
-            <a:off x="914400" y="1828800"/>
-            <a:ext cx="7315200" cy="457200"/>
-          </a:xfrm>
-          <a:prstGeom prst="rect">
-            <a:avLst/>
-          </a:prstGeom>
-          <a:noFill/>
-          <a:ln/>
-        </p:spPr>
-        <p:txBody>
-          <a:bodyPr wrap="square" rtlCol="0" anchor="ctr"/>
-          <a:lstStyle/>
-          <a:p>
-            <a:pPr indent="0" marL="0">
-              <a:buNone/>
-            </a:pPr>
-            <a:r>
-              <a:rPr lang="en-US" dirty="0">
-                <a:solidFill>
-                  <a:srgbClr val="000000"/>
-                </a:solidFill>
-              </a:rPr>
-              <a:t>Location: Global</a:t>
-            </a:r>
-            <a:endParaRPr lang="en-US" dirty="0"/>
-          </a:p>
-        </p:txBody>
-      </p:sp>
-      <p:sp>
-        <p:nvSpPr>
-          <p:cNvPr id="4" name="Text 2"/>
-          <p:cNvSpPr/>
-          <p:nvPr/>
-        </p:nvSpPr>
-        <p:spPr>
-          <a:xfrm>
-            <a:off x="914400" y="2286000"/>
-            <a:ext cx="7315200" cy="457200"/>
-          </a:xfrm>
-          <a:prstGeom prst="rect">
-            <a:avLst/>
-          </a:prstGeom>
-          <a:noFill/>
-          <a:ln/>
-        </p:spPr>
-        <p:txBody>
-          <a:bodyPr wrap="square" rtlCol="0" anchor="ctr"/>
-          <a:lstStyle/>
-          <a:p>
-            <a:pPr indent="0" marL="0">
-              <a:buNone/>
-            </a:pPr>
-            <a:r>
-              <a:rPr lang="en-US" dirty="0">
-                <a:solidFill>
-                  <a:srgbClr val="000000"/>
-                </a:solidFill>
-              </a:rPr>
-              <a:t>Gender: Mixed</a:t>
-            </a:r>
-            <a:endParaRPr lang="en-US" dirty="0"/>
-          </a:p>
-        </p:txBody>
-      </p:sp>
+        </p:nvGraphicFramePr>
+        <p:xfrm>
+          <a:off x="914400" y="1828800"/>
+          <a:ext cx="7315200" cy="3657600"/>
+        </p:xfrm>
+        <a:graphic xmlns:a="http://schemas.openxmlformats.org/drawingml/2006/main">
+          <a:graphicData uri="http://schemas.openxmlformats.org/drawingml/2006/chart">
+            <c:chart xmlns:c="http://schemas.openxmlformats.org/drawingml/2006/chart" r:id="rId1"/>
+          </a:graphicData>
+        </a:graphic>
+      </p:graphicFrame>
     </p:spTree>
   </p:cSld>
   <p:clrMapOvr>
@@ -1672,18 +1915,18 @@
           <a:bodyPr wrap="square" rtlCol="0" anchor="ctr"/>
           <a:lstStyle/>
           <a:p>
-            <a:pPr indent="0" marL="0">
+            <a:pPr algn="ctr" indent="0" marL="0">
               <a:buNone/>
             </a:pPr>
             <a:r>
-              <a:rPr lang="en-US" sz="2400" dirty="0">
+              <a:rPr lang="en-US" sz="3600" b="1" dirty="0">
                 <a:solidFill>
                   <a:srgbClr val="000000"/>
                 </a:solidFill>
               </a:rPr>
               <a:t>Executive Summary</a:t>
             </a:r>
-            <a:endParaRPr lang="en-US" sz="2400" dirty="0"/>
+            <a:endParaRPr lang="en-US" sz="3600" dirty="0"/>
           </a:p>
         </p:txBody>
       </p:sp>
@@ -1695,8 +1938,8 @@
         </p:nvSpPr>
         <p:spPr>
           <a:xfrm>
-            <a:off x="914400" y="1828800"/>
-            <a:ext cx="7315200" cy="4114800"/>
+            <a:off x="914400" y="2286000"/>
+            <a:ext cx="7315200" cy="3657600"/>
           </a:xfrm>
           <a:prstGeom prst="rect">
             <a:avLst/>
@@ -1708,18 +1951,18 @@
           <a:bodyPr wrap="square" rtlCol="0" anchor="ctr"/>
           <a:lstStyle/>
           <a:p>
-            <a:pPr indent="0" marL="0">
+            <a:pPr algn="l" indent="0" marL="0">
               <a:buNone/>
             </a:pPr>
             <a:r>
-              <a:rPr lang="en-US" dirty="0">
+              <a:rPr lang="en-US" sz="1800" dirty="0">
                 <a:solidFill>
                   <a:srgbClr val="000000"/>
                 </a:solidFill>
               </a:rPr>
               <a:t>This is a test executive summary.</a:t>
             </a:r>
-            <a:endParaRPr lang="en-US" dirty="0"/>
+            <a:endParaRPr lang="en-US" sz="1800" dirty="0"/>
           </a:p>
         </p:txBody>
       </p:sp>
@@ -1769,18 +2012,18 @@
           <a:bodyPr wrap="square" rtlCol="0" anchor="ctr"/>
           <a:lstStyle/>
           <a:p>
-            <a:pPr indent="0" marL="0">
+            <a:pPr algn="ctr" indent="0" marL="0">
               <a:buNone/>
             </a:pPr>
             <a:r>
-              <a:rPr lang="en-US" sz="2400" dirty="0">
+              <a:rPr lang="en-US" sz="3600" b="1" dirty="0">
                 <a:solidFill>
                   <a:srgbClr val="000000"/>
                 </a:solidFill>
               </a:rPr>
               <a:t>Core Insight Areas</a:t>
             </a:r>
-            <a:endParaRPr lang="en-US" sz="2400" dirty="0"/>
+            <a:endParaRPr lang="en-US" sz="3600" dirty="0"/>
           </a:p>
         </p:txBody>
       </p:sp>
@@ -1792,8 +2035,8 @@
         </p:nvSpPr>
         <p:spPr>
           <a:xfrm>
-            <a:off x="914400" y="1828800"/>
-            <a:ext cx="7315200" cy="4114800"/>
+            <a:off x="914400" y="2286000"/>
+            <a:ext cx="7315200" cy="3657600"/>
           </a:xfrm>
           <a:prstGeom prst="rect">
             <a:avLst/>
@@ -1805,18 +2048,18 @@
           <a:bodyPr wrap="square" rtlCol="0" anchor="ctr"/>
           <a:lstStyle/>
           <a:p>
-            <a:pPr indent="0" marL="0">
+            <a:pPr algn="l" indent="0" marL="0">
               <a:buNone/>
             </a:pPr>
             <a:r>
-              <a:rPr lang="en-US" dirty="0">
+              <a:rPr lang="en-US" sz="1800" dirty="0">
                 <a:solidFill>
                   <a:srgbClr val="000000"/>
                 </a:solidFill>
               </a:rPr>
               <a:t>These are test core insights.</a:t>
             </a:r>
-            <a:endParaRPr lang="en-US" dirty="0"/>
+            <a:endParaRPr lang="en-US" sz="1800" dirty="0"/>
           </a:p>
         </p:txBody>
       </p:sp>
@@ -1866,18 +2109,18 @@
           <a:bodyPr wrap="square" rtlCol="0" anchor="ctr"/>
           <a:lstStyle/>
           <a:p>
-            <a:pPr indent="0" marL="0">
+            <a:pPr algn="ctr" indent="0" marL="0">
               <a:buNone/>
             </a:pPr>
             <a:r>
-              <a:rPr lang="en-US" sz="2400" dirty="0">
+              <a:rPr lang="en-US" sz="3600" b="1" dirty="0">
                 <a:solidFill>
                   <a:srgbClr val="000000"/>
                 </a:solidFill>
               </a:rPr>
               <a:t>Regional and Outlet-Level Findings</a:t>
             </a:r>
-            <a:endParaRPr lang="en-US" sz="2400" dirty="0"/>
+            <a:endParaRPr lang="en-US" sz="3600" dirty="0"/>
           </a:p>
         </p:txBody>
       </p:sp>
@@ -1889,8 +2132,8 @@
         </p:nvSpPr>
         <p:spPr>
           <a:xfrm>
-            <a:off x="914400" y="1828800"/>
-            <a:ext cx="7315200" cy="4114800"/>
+            <a:off x="914400" y="2286000"/>
+            <a:ext cx="7315200" cy="3657600"/>
           </a:xfrm>
           <a:prstGeom prst="rect">
             <a:avLst/>
@@ -1902,18 +2145,18 @@
           <a:bodyPr wrap="square" rtlCol="0" anchor="ctr"/>
           <a:lstStyle/>
           <a:p>
-            <a:pPr indent="0" marL="0">
+            <a:pPr algn="l" indent="0" marL="0">
               <a:buNone/>
             </a:pPr>
             <a:r>
-              <a:rPr lang="en-US" dirty="0">
+              <a:rPr lang="en-US" sz="1800" dirty="0">
                 <a:solidFill>
                   <a:srgbClr val="000000"/>
                 </a:solidFill>
               </a:rPr>
               <a:t>These are test regional findings.</a:t>
             </a:r>
-            <a:endParaRPr lang="en-US" dirty="0"/>
+            <a:endParaRPr lang="en-US" sz="1800" dirty="0"/>
           </a:p>
         </p:txBody>
       </p:sp>
@@ -1963,18 +2206,18 @@
           <a:bodyPr wrap="square" rtlCol="0" anchor="ctr"/>
           <a:lstStyle/>
           <a:p>
-            <a:pPr indent="0" marL="0">
+            <a:pPr algn="ctr" indent="0" marL="0">
               <a:buNone/>
             </a:pPr>
             <a:r>
-              <a:rPr lang="en-US" sz="2400" dirty="0">
+              <a:rPr lang="en-US" sz="3600" b="1" dirty="0">
                 <a:solidFill>
                   <a:srgbClr val="000000"/>
                 </a:solidFill>
               </a:rPr>
               <a:t>Recommendations</a:t>
             </a:r>
-            <a:endParaRPr lang="en-US" sz="2400" dirty="0"/>
+            <a:endParaRPr lang="en-US" sz="3600" dirty="0"/>
           </a:p>
         </p:txBody>
       </p:sp>
@@ -1986,8 +2229,8 @@
         </p:nvSpPr>
         <p:spPr>
           <a:xfrm>
-            <a:off x="914400" y="1828800"/>
-            <a:ext cx="7315200" cy="4114800"/>
+            <a:off x="914400" y="2286000"/>
+            <a:ext cx="7315200" cy="3657600"/>
           </a:xfrm>
           <a:prstGeom prst="rect">
             <a:avLst/>
@@ -1999,18 +2242,18 @@
           <a:bodyPr wrap="square" rtlCol="0" anchor="ctr"/>
           <a:lstStyle/>
           <a:p>
-            <a:pPr indent="0" marL="0">
+            <a:pPr algn="l" indent="0" marL="0">
               <a:buNone/>
             </a:pPr>
             <a:r>
-              <a:rPr lang="en-US" dirty="0">
+              <a:rPr lang="en-US" sz="1800" dirty="0">
                 <a:solidFill>
                   <a:srgbClr val="000000"/>
                 </a:solidFill>
               </a:rPr>
               <a:t>These are test recommendations.</a:t>
             </a:r>
-            <a:endParaRPr lang="en-US" dirty="0"/>
+            <a:endParaRPr lang="en-US" sz="1800" dirty="0"/>
           </a:p>
         </p:txBody>
       </p:sp>

</xml_diff>